<commit_message>
updated flowchart with nw-page
</commit_message>
<xml_diff>
--- a/assets/media/epitome-v2.0.pptx
+++ b/assets/media/epitome-v2.0.pptx
@@ -115,64 +115,17 @@
 </p:presentation>
 </file>
 
-<file path=ppt/revisionInfo.xml><?xml version="1.0" encoding="utf-8"?>
-<p1510:revInfo xmlns:a="http://schemas.openxmlformats.org/drawingml/2006/main" xmlns:r="http://schemas.openxmlformats.org/officeDocument/2006/relationships" xmlns:p1510="http://schemas.microsoft.com/office/powerpoint/2015/10/main">
-  <p1510:revLst>
-    <p1510:client id="{B850BABA-B69E-44EF-945E-A30A256A3564}" v="190" dt="2026-03-12T16:04:30.181"/>
-  </p1510:revLst>
-</p1510:revInfo>
-</file>
-
 <file path=ppt/changesInfos/changesInfo1.xml><?xml version="1.0" encoding="utf-8"?>
 <pc:chgInfo xmlns:a="http://schemas.openxmlformats.org/drawingml/2006/main" xmlns:r="http://schemas.openxmlformats.org/officeDocument/2006/relationships" xmlns:ac="http://schemas.microsoft.com/office/drawing/2013/main/command" xmlns:pc="http://schemas.microsoft.com/office/powerpoint/2013/main/command">
   <pc:docChgLst>
     <pc:chgData name="Johnson, Jared D (DOH)" userId="92504013-c597-429b-a67d-c586dbfe9781" providerId="ADAL" clId="{A79EF7B5-D90B-4A7E-A208-864AEE145536}"/>
     <pc:docChg chg="undo custSel addSld delSld modSld">
-      <pc:chgData name="Johnson, Jared D (DOH)" userId="92504013-c597-429b-a67d-c586dbfe9781" providerId="ADAL" clId="{A79EF7B5-D90B-4A7E-A208-864AEE145536}" dt="2026-03-12T16:05:47.572" v="2861" actId="14100"/>
+      <pc:chgData name="Johnson, Jared D (DOH)" userId="92504013-c597-429b-a67d-c586dbfe9781" providerId="ADAL" clId="{A79EF7B5-D90B-4A7E-A208-864AEE145536}" dt="2026-04-03T20:21:28.633" v="2873" actId="1076"/>
       <pc:docMkLst>
         <pc:docMk/>
       </pc:docMkLst>
-      <pc:sldChg chg="addSp delSp modSp del mod">
-        <pc:chgData name="Johnson, Jared D (DOH)" userId="92504013-c597-429b-a67d-c586dbfe9781" providerId="ADAL" clId="{A79EF7B5-D90B-4A7E-A208-864AEE145536}" dt="2026-03-11T22:44:01.282" v="1733" actId="47"/>
-        <pc:sldMkLst>
-          <pc:docMk/>
-          <pc:sldMk cId="3153397738" sldId="257"/>
-        </pc:sldMkLst>
-        <pc:spChg chg="mod">
-          <ac:chgData name="Johnson, Jared D (DOH)" userId="92504013-c597-429b-a67d-c586dbfe9781" providerId="ADAL" clId="{A79EF7B5-D90B-4A7E-A208-864AEE145536}" dt="2026-03-11T21:57:53.783" v="349" actId="20577"/>
-          <ac:spMkLst>
-            <pc:docMk/>
-            <pc:sldMk cId="3153397738" sldId="257"/>
-            <ac:spMk id="11" creationId="{F9EFFDEF-702E-CEA6-82BB-3AD1BA5CBE8B}"/>
-          </ac:spMkLst>
-        </pc:spChg>
-        <pc:spChg chg="mod">
-          <ac:chgData name="Johnson, Jared D (DOH)" userId="92504013-c597-429b-a67d-c586dbfe9781" providerId="ADAL" clId="{A79EF7B5-D90B-4A7E-A208-864AEE145536}" dt="2026-03-11T21:57:28.371" v="306" actId="20577"/>
-          <ac:spMkLst>
-            <pc:docMk/>
-            <pc:sldMk cId="3153397738" sldId="257"/>
-            <ac:spMk id="1311" creationId="{CA881000-2328-D662-6E51-3034FE506D25}"/>
-          </ac:spMkLst>
-        </pc:spChg>
-        <pc:picChg chg="add mod">
-          <ac:chgData name="Johnson, Jared D (DOH)" userId="92504013-c597-429b-a67d-c586dbfe9781" providerId="ADAL" clId="{A79EF7B5-D90B-4A7E-A208-864AEE145536}" dt="2026-03-11T21:57:18.572" v="295" actId="1076"/>
-          <ac:picMkLst>
-            <pc:docMk/>
-            <pc:sldMk cId="3153397738" sldId="257"/>
-            <ac:picMk id="3" creationId="{554A1449-169A-5C70-9637-19601E61EA89}"/>
-          </ac:picMkLst>
-        </pc:picChg>
-        <pc:picChg chg="add del mod">
-          <ac:chgData name="Johnson, Jared D (DOH)" userId="92504013-c597-429b-a67d-c586dbfe9781" providerId="ADAL" clId="{A79EF7B5-D90B-4A7E-A208-864AEE145536}" dt="2026-03-11T21:52:45.983" v="224" actId="478"/>
-          <ac:picMkLst>
-            <pc:docMk/>
-            <pc:sldMk cId="3153397738" sldId="257"/>
-            <ac:picMk id="1470" creationId="{931A1DD3-57BB-8D61-681D-90DA784F842F}"/>
-          </ac:picMkLst>
-        </pc:picChg>
-      </pc:sldChg>
       <pc:sldChg chg="addSp delSp modSp add mod">
-        <pc:chgData name="Johnson, Jared D (DOH)" userId="92504013-c597-429b-a67d-c586dbfe9781" providerId="ADAL" clId="{A79EF7B5-D90B-4A7E-A208-864AEE145536}" dt="2026-03-12T16:05:47.572" v="2861" actId="14100"/>
+        <pc:chgData name="Johnson, Jared D (DOH)" userId="92504013-c597-429b-a67d-c586dbfe9781" providerId="ADAL" clId="{A79EF7B5-D90B-4A7E-A208-864AEE145536}" dt="2026-04-03T20:21:28.633" v="2873" actId="1076"/>
         <pc:sldMkLst>
           <pc:docMk/>
           <pc:sldMk cId="1410328859" sldId="258"/>
@@ -185,28 +138,12 @@
             <ac:spMk id="2" creationId="{4118F1D9-63F5-6B15-D3D4-9A22D63047B9}"/>
           </ac:spMkLst>
         </pc:spChg>
-        <pc:spChg chg="del">
-          <ac:chgData name="Johnson, Jared D (DOH)" userId="92504013-c597-429b-a67d-c586dbfe9781" providerId="ADAL" clId="{A79EF7B5-D90B-4A7E-A208-864AEE145536}" dt="2026-03-11T22:03:33.341" v="351" actId="478"/>
-          <ac:spMkLst>
-            <pc:docMk/>
-            <pc:sldMk cId="1410328859" sldId="258"/>
-            <ac:spMk id="8" creationId="{BFC4F0FB-A61A-51DA-084A-29356B336630}"/>
-          </ac:spMkLst>
-        </pc:spChg>
         <pc:spChg chg="mod">
           <ac:chgData name="Johnson, Jared D (DOH)" userId="92504013-c597-429b-a67d-c586dbfe9781" providerId="ADAL" clId="{A79EF7B5-D90B-4A7E-A208-864AEE145536}" dt="2026-03-12T16:03:28.691" v="2806" actId="14100"/>
           <ac:spMkLst>
             <pc:docMk/>
             <pc:sldMk cId="1410328859" sldId="258"/>
             <ac:spMk id="14" creationId="{39892FCC-FB03-4C98-DF8E-13440AFDFABE}"/>
-          </ac:spMkLst>
-        </pc:spChg>
-        <pc:spChg chg="del">
-          <ac:chgData name="Johnson, Jared D (DOH)" userId="92504013-c597-429b-a67d-c586dbfe9781" providerId="ADAL" clId="{A79EF7B5-D90B-4A7E-A208-864AEE145536}" dt="2026-03-11T22:03:33.341" v="351" actId="478"/>
-          <ac:spMkLst>
-            <pc:docMk/>
-            <pc:sldMk cId="1410328859" sldId="258"/>
-            <ac:spMk id="25" creationId="{16197368-9246-EC6C-B92D-E55FBC5F24F7}"/>
           </ac:spMkLst>
         </pc:spChg>
         <pc:spChg chg="mod">
@@ -305,22 +242,6 @@
             <ac:spMk id="1047" creationId="{02D255A9-DFCA-0F59-CBBE-4F3C69B83556}"/>
           </ac:spMkLst>
         </pc:spChg>
-        <pc:spChg chg="del">
-          <ac:chgData name="Johnson, Jared D (DOH)" userId="92504013-c597-429b-a67d-c586dbfe9781" providerId="ADAL" clId="{A79EF7B5-D90B-4A7E-A208-864AEE145536}" dt="2026-03-11T22:03:33.341" v="351" actId="478"/>
-          <ac:spMkLst>
-            <pc:docMk/>
-            <pc:sldMk cId="1410328859" sldId="258"/>
-            <ac:spMk id="1077" creationId="{651FFDD1-F419-526C-5D55-B2F192C4E4E1}"/>
-          </ac:spMkLst>
-        </pc:spChg>
-        <pc:spChg chg="del">
-          <ac:chgData name="Johnson, Jared D (DOH)" userId="92504013-c597-429b-a67d-c586dbfe9781" providerId="ADAL" clId="{A79EF7B5-D90B-4A7E-A208-864AEE145536}" dt="2026-03-11T22:03:33.341" v="351" actId="478"/>
-          <ac:spMkLst>
-            <pc:docMk/>
-            <pc:sldMk cId="1410328859" sldId="258"/>
-            <ac:spMk id="1079" creationId="{8EAD3215-A549-A1DB-523D-CC4E1F70AF22}"/>
-          </ac:spMkLst>
-        </pc:spChg>
         <pc:spChg chg="add mod">
           <ac:chgData name="Johnson, Jared D (DOH)" userId="92504013-c597-429b-a67d-c586dbfe9781" providerId="ADAL" clId="{A79EF7B5-D90B-4A7E-A208-864AEE145536}" dt="2026-03-11T23:06:37.697" v="2082" actId="1076"/>
           <ac:spMkLst>
@@ -335,14 +256,6 @@
             <pc:docMk/>
             <pc:sldMk cId="1410328859" sldId="258"/>
             <ac:spMk id="1115" creationId="{37C3B4E6-53EA-16EE-6966-8881380060AA}"/>
-          </ac:spMkLst>
-        </pc:spChg>
-        <pc:spChg chg="add del mod">
-          <ac:chgData name="Johnson, Jared D (DOH)" userId="92504013-c597-429b-a67d-c586dbfe9781" providerId="ADAL" clId="{A79EF7B5-D90B-4A7E-A208-864AEE145536}" dt="2026-03-12T15:54:33.509" v="2430" actId="478"/>
-          <ac:spMkLst>
-            <pc:docMk/>
-            <pc:sldMk cId="1410328859" sldId="258"/>
-            <ac:spMk id="1155" creationId="{785FDFD0-3376-4C95-B705-78FC943B3FA7}"/>
           </ac:spMkLst>
         </pc:spChg>
         <pc:spChg chg="add mod">
@@ -361,28 +274,12 @@
             <ac:spMk id="1167" creationId="{446A1698-1225-53B4-1AFA-18190F1C7162}"/>
           </ac:spMkLst>
         </pc:spChg>
-        <pc:spChg chg="del">
-          <ac:chgData name="Johnson, Jared D (DOH)" userId="92504013-c597-429b-a67d-c586dbfe9781" providerId="ADAL" clId="{A79EF7B5-D90B-4A7E-A208-864AEE145536}" dt="2026-03-11T22:03:33.341" v="351" actId="478"/>
-          <ac:spMkLst>
-            <pc:docMk/>
-            <pc:sldMk cId="1410328859" sldId="258"/>
-            <ac:spMk id="1174" creationId="{D955C4BB-49B7-D5E4-8107-23FE30396880}"/>
-          </ac:spMkLst>
-        </pc:spChg>
         <pc:spChg chg="add mod">
           <ac:chgData name="Johnson, Jared D (DOH)" userId="92504013-c597-429b-a67d-c586dbfe9781" providerId="ADAL" clId="{A79EF7B5-D90B-4A7E-A208-864AEE145536}" dt="2026-03-12T15:57:36.823" v="2614" actId="14100"/>
           <ac:spMkLst>
             <pc:docMk/>
             <pc:sldMk cId="1410328859" sldId="258"/>
             <ac:spMk id="1175" creationId="{C1A234AB-A0DF-BE76-D308-CABAF1575FEB}"/>
-          </ac:spMkLst>
-        </pc:spChg>
-        <pc:spChg chg="add del mod">
-          <ac:chgData name="Johnson, Jared D (DOH)" userId="92504013-c597-429b-a67d-c586dbfe9781" providerId="ADAL" clId="{A79EF7B5-D90B-4A7E-A208-864AEE145536}" dt="2026-03-12T15:58:28.379" v="2665" actId="478"/>
-          <ac:spMkLst>
-            <pc:docMk/>
-            <pc:sldMk cId="1410328859" sldId="258"/>
-            <ac:spMk id="1181" creationId="{E0C39F37-B250-9807-D8B3-426A12CC0247}"/>
           </ac:spMkLst>
         </pc:spChg>
         <pc:spChg chg="add mod">
@@ -393,28 +290,12 @@
             <ac:spMk id="1188" creationId="{82FF13AD-7695-9519-E616-70EF73C1B793}"/>
           </ac:spMkLst>
         </pc:spChg>
-        <pc:spChg chg="del">
-          <ac:chgData name="Johnson, Jared D (DOH)" userId="92504013-c597-429b-a67d-c586dbfe9781" providerId="ADAL" clId="{A79EF7B5-D90B-4A7E-A208-864AEE145536}" dt="2026-03-11T22:03:33.341" v="351" actId="478"/>
+        <pc:spChg chg="mod">
+          <ac:chgData name="Johnson, Jared D (DOH)" userId="92504013-c597-429b-a67d-c586dbfe9781" providerId="ADAL" clId="{A79EF7B5-D90B-4A7E-A208-864AEE145536}" dt="2026-04-03T20:20:58.507" v="2870" actId="20577"/>
           <ac:spMkLst>
             <pc:docMk/>
             <pc:sldMk cId="1410328859" sldId="258"/>
-            <ac:spMk id="1207" creationId="{B14DFBCC-8897-0FE8-A222-440199A38232}"/>
-          </ac:spMkLst>
-        </pc:spChg>
-        <pc:spChg chg="del">
-          <ac:chgData name="Johnson, Jared D (DOH)" userId="92504013-c597-429b-a67d-c586dbfe9781" providerId="ADAL" clId="{A79EF7B5-D90B-4A7E-A208-864AEE145536}" dt="2026-03-11T22:03:33.341" v="351" actId="478"/>
-          <ac:spMkLst>
-            <pc:docMk/>
-            <pc:sldMk cId="1410328859" sldId="258"/>
-            <ac:spMk id="1209" creationId="{2B46A04E-3AB8-CE13-459A-9158C39F4E5D}"/>
-          </ac:spMkLst>
-        </pc:spChg>
-        <pc:spChg chg="del">
-          <ac:chgData name="Johnson, Jared D (DOH)" userId="92504013-c597-429b-a67d-c586dbfe9781" providerId="ADAL" clId="{A79EF7B5-D90B-4A7E-A208-864AEE145536}" dt="2026-03-11T22:03:33.341" v="351" actId="478"/>
-          <ac:spMkLst>
-            <pc:docMk/>
-            <pc:sldMk cId="1410328859" sldId="258"/>
-            <ac:spMk id="1290" creationId="{040F51ED-2D46-51E0-3C02-13B7C0894734}"/>
+            <ac:spMk id="1311" creationId="{43636745-667E-B3C5-3152-2F31A9A53D87}"/>
           </ac:spMkLst>
         </pc:spChg>
         <pc:spChg chg="add mod">
@@ -423,14 +304,6 @@
             <pc:docMk/>
             <pc:sldMk cId="1410328859" sldId="258"/>
             <ac:spMk id="1408" creationId="{F3BC546F-5C88-7245-4C60-0181DB7D008F}"/>
-          </ac:spMkLst>
-        </pc:spChg>
-        <pc:spChg chg="add del mod">
-          <ac:chgData name="Johnson, Jared D (DOH)" userId="92504013-c597-429b-a67d-c586dbfe9781" providerId="ADAL" clId="{A79EF7B5-D90B-4A7E-A208-864AEE145536}" dt="2026-03-11T22:37:25.970" v="1618" actId="478"/>
-          <ac:spMkLst>
-            <pc:docMk/>
-            <pc:sldMk cId="1410328859" sldId="258"/>
-            <ac:spMk id="1409" creationId="{0E0B460F-24EF-8A11-31A5-C80EB0D6F038}"/>
           </ac:spMkLst>
         </pc:spChg>
         <pc:spChg chg="add mod">
@@ -447,14 +320,6 @@
             <pc:docMk/>
             <pc:sldMk cId="1410328859" sldId="258"/>
             <ac:spMk id="1411" creationId="{D22F02D0-3AFB-B79E-0AE1-8F468284217C}"/>
-          </ac:spMkLst>
-        </pc:spChg>
-        <pc:spChg chg="add del mod">
-          <ac:chgData name="Johnson, Jared D (DOH)" userId="92504013-c597-429b-a67d-c586dbfe9781" providerId="ADAL" clId="{A79EF7B5-D90B-4A7E-A208-864AEE145536}" dt="2026-03-11T22:37:28.501" v="1620" actId="478"/>
-          <ac:spMkLst>
-            <pc:docMk/>
-            <pc:sldMk cId="1410328859" sldId="258"/>
-            <ac:spMk id="1413" creationId="{65216C3E-1038-D5DE-E805-BE47C1DFF203}"/>
           </ac:spMkLst>
         </pc:spChg>
         <pc:spChg chg="add mod">
@@ -487,22 +352,6 @@
             <pc:docMk/>
             <pc:sldMk cId="1410328859" sldId="258"/>
             <ac:spMk id="1418" creationId="{7DECE961-C696-CB14-A2E9-A36A75C1AB0E}"/>
-          </ac:spMkLst>
-        </pc:spChg>
-        <pc:spChg chg="add del mod">
-          <ac:chgData name="Johnson, Jared D (DOH)" userId="92504013-c597-429b-a67d-c586dbfe9781" providerId="ADAL" clId="{A79EF7B5-D90B-4A7E-A208-864AEE145536}" dt="2026-03-11T22:12:23.179" v="890" actId="478"/>
-          <ac:spMkLst>
-            <pc:docMk/>
-            <pc:sldMk cId="1410328859" sldId="258"/>
-            <ac:spMk id="1419" creationId="{60C39650-8EA5-5C8E-5026-6891DD94D846}"/>
-          </ac:spMkLst>
-        </pc:spChg>
-        <pc:spChg chg="add del mod">
-          <ac:chgData name="Johnson, Jared D (DOH)" userId="92504013-c597-429b-a67d-c586dbfe9781" providerId="ADAL" clId="{A79EF7B5-D90B-4A7E-A208-864AEE145536}" dt="2026-03-11T22:12:22.050" v="889" actId="478"/>
-          <ac:spMkLst>
-            <pc:docMk/>
-            <pc:sldMk cId="1410328859" sldId="258"/>
-            <ac:spMk id="1420" creationId="{C41E749D-08F4-124B-5CB9-F252ACF2714B}"/>
           </ac:spMkLst>
         </pc:spChg>
         <pc:spChg chg="add mod">
@@ -543,30 +392,6 @@
             <pc:docMk/>
             <pc:sldMk cId="1410328859" sldId="258"/>
             <ac:spMk id="1425" creationId="{BE4FA7A5-1FB3-2EAD-15EF-9E780CF346DB}"/>
-          </ac:spMkLst>
-        </pc:spChg>
-        <pc:spChg chg="add del mod">
-          <ac:chgData name="Johnson, Jared D (DOH)" userId="92504013-c597-429b-a67d-c586dbfe9781" providerId="ADAL" clId="{A79EF7B5-D90B-4A7E-A208-864AEE145536}" dt="2026-03-11T22:27:24.679" v="1338" actId="478"/>
-          <ac:spMkLst>
-            <pc:docMk/>
-            <pc:sldMk cId="1410328859" sldId="258"/>
-            <ac:spMk id="1426" creationId="{6D9D015F-AA12-8864-A2F4-B10ADBD0ABF1}"/>
-          </ac:spMkLst>
-        </pc:spChg>
-        <pc:spChg chg="add del mod">
-          <ac:chgData name="Johnson, Jared D (DOH)" userId="92504013-c597-429b-a67d-c586dbfe9781" providerId="ADAL" clId="{A79EF7B5-D90B-4A7E-A208-864AEE145536}" dt="2026-03-11T22:27:24.679" v="1338" actId="478"/>
-          <ac:spMkLst>
-            <pc:docMk/>
-            <pc:sldMk cId="1410328859" sldId="258"/>
-            <ac:spMk id="1427" creationId="{F8CF151A-3F14-4FDC-9A78-D7DCA22C9A96}"/>
-          </ac:spMkLst>
-        </pc:spChg>
-        <pc:spChg chg="add del mod">
-          <ac:chgData name="Johnson, Jared D (DOH)" userId="92504013-c597-429b-a67d-c586dbfe9781" providerId="ADAL" clId="{A79EF7B5-D90B-4A7E-A208-864AEE145536}" dt="2026-03-11T22:15:56.503" v="987" actId="478"/>
-          <ac:spMkLst>
-            <pc:docMk/>
-            <pc:sldMk cId="1410328859" sldId="258"/>
-            <ac:spMk id="1428" creationId="{30ED165C-BA53-5723-B735-F962B244877B}"/>
           </ac:spMkLst>
         </pc:spChg>
         <pc:spChg chg="add del mod">
@@ -617,22 +442,6 @@
             <ac:spMk id="1434" creationId="{E94E065C-45FE-3562-AA1F-5F36F9D3C366}"/>
           </ac:spMkLst>
         </pc:spChg>
-        <pc:spChg chg="add del mod ord">
-          <ac:chgData name="Johnson, Jared D (DOH)" userId="92504013-c597-429b-a67d-c586dbfe9781" providerId="ADAL" clId="{A79EF7B5-D90B-4A7E-A208-864AEE145536}" dt="2026-03-11T22:24:12.536" v="1225" actId="478"/>
-          <ac:spMkLst>
-            <pc:docMk/>
-            <pc:sldMk cId="1410328859" sldId="258"/>
-            <ac:spMk id="1435" creationId="{B053D075-F0E5-0948-3B6C-1931CDFDC6DD}"/>
-          </ac:spMkLst>
-        </pc:spChg>
-        <pc:spChg chg="add del mod ord">
-          <ac:chgData name="Johnson, Jared D (DOH)" userId="92504013-c597-429b-a67d-c586dbfe9781" providerId="ADAL" clId="{A79EF7B5-D90B-4A7E-A208-864AEE145536}" dt="2026-03-11T22:24:13.983" v="1226" actId="478"/>
-          <ac:spMkLst>
-            <pc:docMk/>
-            <pc:sldMk cId="1410328859" sldId="258"/>
-            <ac:spMk id="1436" creationId="{57D44732-2DCF-5420-3438-ACBB33B10BEC}"/>
-          </ac:spMkLst>
-        </pc:spChg>
         <pc:spChg chg="add mod">
           <ac:chgData name="Johnson, Jared D (DOH)" userId="92504013-c597-429b-a67d-c586dbfe9781" providerId="ADAL" clId="{A79EF7B5-D90B-4A7E-A208-864AEE145536}" dt="2026-03-12T15:15:43.564" v="2212" actId="692"/>
           <ac:spMkLst>
@@ -647,22 +456,6 @@
             <pc:docMk/>
             <pc:sldMk cId="1410328859" sldId="258"/>
             <ac:spMk id="1438" creationId="{263EF19D-B3D5-7BED-9BF1-312DB05FB2EB}"/>
-          </ac:spMkLst>
-        </pc:spChg>
-        <pc:spChg chg="add del mod">
-          <ac:chgData name="Johnson, Jared D (DOH)" userId="92504013-c597-429b-a67d-c586dbfe9781" providerId="ADAL" clId="{A79EF7B5-D90B-4A7E-A208-864AEE145536}" dt="2026-03-11T22:37:27.513" v="1619" actId="478"/>
-          <ac:spMkLst>
-            <pc:docMk/>
-            <pc:sldMk cId="1410328859" sldId="258"/>
-            <ac:spMk id="1439" creationId="{9420F4A8-BA7D-BD9D-ADA1-78535B92ECA5}"/>
-          </ac:spMkLst>
-        </pc:spChg>
-        <pc:spChg chg="add del mod">
-          <ac:chgData name="Johnson, Jared D (DOH)" userId="92504013-c597-429b-a67d-c586dbfe9781" providerId="ADAL" clId="{A79EF7B5-D90B-4A7E-A208-864AEE145536}" dt="2026-03-11T22:23:57.088" v="1190" actId="478"/>
-          <ac:spMkLst>
-            <pc:docMk/>
-            <pc:sldMk cId="1410328859" sldId="258"/>
-            <ac:spMk id="1440" creationId="{86640B09-3358-90E0-0121-C1E16F685135}"/>
           </ac:spMkLst>
         </pc:spChg>
         <pc:spChg chg="add mod">
@@ -714,14 +507,6 @@
           </ac:spMkLst>
         </pc:spChg>
         <pc:spChg chg="mod">
-          <ac:chgData name="Johnson, Jared D (DOH)" userId="92504013-c597-429b-a67d-c586dbfe9781" providerId="ADAL" clId="{A79EF7B5-D90B-4A7E-A208-864AEE145536}" dt="2026-03-11T22:29:30.075" v="1356"/>
-          <ac:spMkLst>
-            <pc:docMk/>
-            <pc:sldMk cId="1410328859" sldId="258"/>
-            <ac:spMk id="1449" creationId="{3DCF5CE5-4E29-DCB5-A9BD-3E5BDBFAF212}"/>
-          </ac:spMkLst>
-        </pc:spChg>
-        <pc:spChg chg="mod">
           <ac:chgData name="Johnson, Jared D (DOH)" userId="92504013-c597-429b-a67d-c586dbfe9781" providerId="ADAL" clId="{A79EF7B5-D90B-4A7E-A208-864AEE145536}" dt="2026-03-11T23:07:15.397" v="2090" actId="1076"/>
           <ac:spMkLst>
             <pc:docMk/>
@@ -769,14 +554,6 @@
             <ac:spMk id="1464" creationId="{7D8D2C48-1FD0-B93B-C92C-880998E07163}"/>
           </ac:spMkLst>
         </pc:spChg>
-        <pc:spChg chg="del">
-          <ac:chgData name="Johnson, Jared D (DOH)" userId="92504013-c597-429b-a67d-c586dbfe9781" providerId="ADAL" clId="{A79EF7B5-D90B-4A7E-A208-864AEE145536}" dt="2026-03-11T22:03:33.341" v="351" actId="478"/>
-          <ac:spMkLst>
-            <pc:docMk/>
-            <pc:sldMk cId="1410328859" sldId="258"/>
-            <ac:spMk id="1467" creationId="{B81C9BEB-43E8-437E-DA02-148E78CE5E6E}"/>
-          </ac:spMkLst>
-        </pc:spChg>
         <pc:spChg chg="add mod ord">
           <ac:chgData name="Johnson, Jared D (DOH)" userId="92504013-c597-429b-a67d-c586dbfe9781" providerId="ADAL" clId="{A79EF7B5-D90B-4A7E-A208-864AEE145536}" dt="2026-03-11T22:57:40.958" v="1924" actId="1076"/>
           <ac:spMkLst>
@@ -801,14 +578,6 @@
             <ac:spMk id="1554" creationId="{03D1A205-919A-C354-9474-0DE2C4A7F4B8}"/>
           </ac:spMkLst>
         </pc:spChg>
-        <pc:spChg chg="add del mod">
-          <ac:chgData name="Johnson, Jared D (DOH)" userId="92504013-c597-429b-a67d-c586dbfe9781" providerId="ADAL" clId="{A79EF7B5-D90B-4A7E-A208-864AEE145536}" dt="2026-03-12T15:49:40.911" v="2303" actId="478"/>
-          <ac:spMkLst>
-            <pc:docMk/>
-            <pc:sldMk cId="1410328859" sldId="258"/>
-            <ac:spMk id="1561" creationId="{1087FB26-CDBF-EDA1-9400-9DD10CA252BB}"/>
-          </ac:spMkLst>
-        </pc:spChg>
         <pc:spChg chg="add mod">
           <ac:chgData name="Johnson, Jared D (DOH)" userId="92504013-c597-429b-a67d-c586dbfe9781" providerId="ADAL" clId="{A79EF7B5-D90B-4A7E-A208-864AEE145536}" dt="2026-03-12T15:53:22.402" v="2370" actId="1076"/>
           <ac:spMkLst>
@@ -823,14 +592,6 @@
             <pc:docMk/>
             <pc:sldMk cId="1410328859" sldId="258"/>
             <ac:spMk id="1595" creationId="{A0705130-B8E9-E463-9F05-B4F68770E2E1}"/>
-          </ac:spMkLst>
-        </pc:spChg>
-        <pc:spChg chg="del">
-          <ac:chgData name="Johnson, Jared D (DOH)" userId="92504013-c597-429b-a67d-c586dbfe9781" providerId="ADAL" clId="{A79EF7B5-D90B-4A7E-A208-864AEE145536}" dt="2026-03-11T22:03:33.341" v="351" actId="478"/>
-          <ac:spMkLst>
-            <pc:docMk/>
-            <pc:sldMk cId="1410328859" sldId="258"/>
-            <ac:spMk id="1635" creationId="{21453F56-74FB-0DAB-2F31-CAB16FEB35F5}"/>
           </ac:spMkLst>
         </pc:spChg>
         <pc:grpChg chg="mod">
@@ -857,36 +618,12 @@
             <ac:grpSpMk id="45" creationId="{8BAC5562-7783-EB16-1329-E33CA1914BA6}"/>
           </ac:grpSpMkLst>
         </pc:grpChg>
-        <pc:grpChg chg="del mod">
-          <ac:chgData name="Johnson, Jared D (DOH)" userId="92504013-c597-429b-a67d-c586dbfe9781" providerId="ADAL" clId="{A79EF7B5-D90B-4A7E-A208-864AEE145536}" dt="2026-03-11T22:29:40.310" v="1359" actId="478"/>
-          <ac:grpSpMkLst>
-            <pc:docMk/>
-            <pc:sldMk cId="1410328859" sldId="258"/>
-            <ac:grpSpMk id="46" creationId="{C423176F-0103-4615-7520-B94EADB8677E}"/>
-          </ac:grpSpMkLst>
-        </pc:grpChg>
         <pc:grpChg chg="add mod">
           <ac:chgData name="Johnson, Jared D (DOH)" userId="92504013-c597-429b-a67d-c586dbfe9781" providerId="ADAL" clId="{A79EF7B5-D90B-4A7E-A208-864AEE145536}" dt="2026-03-11T22:43:53.739" v="1732" actId="1076"/>
           <ac:grpSpMkLst>
             <pc:docMk/>
             <pc:sldMk cId="1410328859" sldId="258"/>
             <ac:grpSpMk id="60" creationId="{B8750692-4D97-31D8-61BB-324D2C78ACF1}"/>
-          </ac:grpSpMkLst>
-        </pc:grpChg>
-        <pc:grpChg chg="add mod">
-          <ac:chgData name="Johnson, Jared D (DOH)" userId="92504013-c597-429b-a67d-c586dbfe9781" providerId="ADAL" clId="{A79EF7B5-D90B-4A7E-A208-864AEE145536}" dt="2026-03-11T22:29:30.075" v="1356"/>
-          <ac:grpSpMkLst>
-            <pc:docMk/>
-            <pc:sldMk cId="1410328859" sldId="258"/>
-            <ac:grpSpMk id="1447" creationId="{40D6F467-9DBC-173D-3565-7012F92507F0}"/>
-          </ac:grpSpMkLst>
-        </pc:grpChg>
-        <pc:grpChg chg="mod">
-          <ac:chgData name="Johnson, Jared D (DOH)" userId="92504013-c597-429b-a67d-c586dbfe9781" providerId="ADAL" clId="{A79EF7B5-D90B-4A7E-A208-864AEE145536}" dt="2026-03-11T22:29:30.075" v="1356"/>
-          <ac:grpSpMkLst>
-            <pc:docMk/>
-            <pc:sldMk cId="1410328859" sldId="258"/>
-            <ac:grpSpMk id="1448" creationId="{85439948-763B-5D3D-4A59-836D4486B59A}"/>
           </ac:grpSpMkLst>
         </pc:grpChg>
         <pc:grpChg chg="add mod">
@@ -930,6 +667,14 @@
           </ac:grpSpMkLst>
         </pc:grpChg>
         <pc:picChg chg="mod">
+          <ac:chgData name="Johnson, Jared D (DOH)" userId="92504013-c597-429b-a67d-c586dbfe9781" providerId="ADAL" clId="{A79EF7B5-D90B-4A7E-A208-864AEE145536}" dt="2026-04-03T20:21:28.633" v="2873" actId="1076"/>
+          <ac:picMkLst>
+            <pc:docMk/>
+            <pc:sldMk cId="1410328859" sldId="258"/>
+            <ac:picMk id="3" creationId="{E1EAFCA7-9C03-9816-6E83-7D8758F19178}"/>
+          </ac:picMkLst>
+        </pc:picChg>
+        <pc:picChg chg="mod">
           <ac:chgData name="Johnson, Jared D (DOH)" userId="92504013-c597-429b-a67d-c586dbfe9781" providerId="ADAL" clId="{A79EF7B5-D90B-4A7E-A208-864AEE145536}" dt="2026-03-12T16:03:28.691" v="2806" actId="14100"/>
           <ac:picMkLst>
             <pc:docMk/>
@@ -951,14 +696,6 @@
             <pc:docMk/>
             <pc:sldMk cId="1410328859" sldId="258"/>
             <ac:picMk id="48" creationId="{B99B2F01-2BFC-F972-9EC8-18F09C5C299C}"/>
-          </ac:picMkLst>
-        </pc:picChg>
-        <pc:picChg chg="del mod">
-          <ac:chgData name="Johnson, Jared D (DOH)" userId="92504013-c597-429b-a67d-c586dbfe9781" providerId="ADAL" clId="{A79EF7B5-D90B-4A7E-A208-864AEE145536}" dt="2026-03-11T22:29:40.310" v="1359" actId="478"/>
-          <ac:picMkLst>
-            <pc:docMk/>
-            <pc:sldMk cId="1410328859" sldId="258"/>
-            <ac:picMk id="49" creationId="{4E281C99-436F-82FD-F74F-4C4E9F8894FD}"/>
           </ac:picMkLst>
         </pc:picChg>
         <pc:picChg chg="add del mod">
@@ -994,22 +731,6 @@
           </ac:picMkLst>
         </pc:picChg>
         <pc:picChg chg="mod">
-          <ac:chgData name="Johnson, Jared D (DOH)" userId="92504013-c597-429b-a67d-c586dbfe9781" providerId="ADAL" clId="{A79EF7B5-D90B-4A7E-A208-864AEE145536}" dt="2026-03-11T22:29:30.075" v="1356"/>
-          <ac:picMkLst>
-            <pc:docMk/>
-            <pc:sldMk cId="1410328859" sldId="258"/>
-            <ac:picMk id="1450" creationId="{6F16927E-7417-255D-624C-7D3B4A4831E6}"/>
-          </ac:picMkLst>
-        </pc:picChg>
-        <pc:picChg chg="mod">
-          <ac:chgData name="Johnson, Jared D (DOH)" userId="92504013-c597-429b-a67d-c586dbfe9781" providerId="ADAL" clId="{A79EF7B5-D90B-4A7E-A208-864AEE145536}" dt="2026-03-11T22:29:30.075" v="1356"/>
-          <ac:picMkLst>
-            <pc:docMk/>
-            <pc:sldMk cId="1410328859" sldId="258"/>
-            <ac:picMk id="1451" creationId="{1599D7F1-9086-E382-E56D-9F087E35561E}"/>
-          </ac:picMkLst>
-        </pc:picChg>
-        <pc:picChg chg="mod">
           <ac:chgData name="Johnson, Jared D (DOH)" userId="92504013-c597-429b-a67d-c586dbfe9781" providerId="ADAL" clId="{A79EF7B5-D90B-4A7E-A208-864AEE145536}" dt="2026-03-11T23:07:15.397" v="2090" actId="1076"/>
           <ac:picMkLst>
             <pc:docMk/>
@@ -1041,22 +762,6 @@
             <ac:picMk id="1609" creationId="{D2F10532-7175-09D4-4272-27E8C3BBB4F8}"/>
           </ac:picMkLst>
         </pc:picChg>
-        <pc:cxnChg chg="del mod">
-          <ac:chgData name="Johnson, Jared D (DOH)" userId="92504013-c597-429b-a67d-c586dbfe9781" providerId="ADAL" clId="{A79EF7B5-D90B-4A7E-A208-864AEE145536}" dt="2026-03-11T22:04:25.113" v="358" actId="478"/>
-          <ac:cxnSpMkLst>
-            <pc:docMk/>
-            <pc:sldMk cId="1410328859" sldId="258"/>
-            <ac:cxnSpMk id="59" creationId="{FC948E37-02C4-5B85-B53E-20062E7F9192}"/>
-          </ac:cxnSpMkLst>
-        </pc:cxnChg>
-        <pc:cxnChg chg="add del mod">
-          <ac:chgData name="Johnson, Jared D (DOH)" userId="92504013-c597-429b-a67d-c586dbfe9781" providerId="ADAL" clId="{A79EF7B5-D90B-4A7E-A208-864AEE145536}" dt="2026-03-11T22:36:37.855" v="1606" actId="478"/>
-          <ac:cxnSpMkLst>
-            <pc:docMk/>
-            <pc:sldMk cId="1410328859" sldId="258"/>
-            <ac:cxnSpMk id="1030" creationId="{B8339A8F-021E-6CBB-8AD7-F5EE76FA822D}"/>
-          </ac:cxnSpMkLst>
-        </pc:cxnChg>
         <pc:cxnChg chg="add mod">
           <ac:chgData name="Johnson, Jared D (DOH)" userId="92504013-c597-429b-a67d-c586dbfe9781" providerId="ADAL" clId="{A79EF7B5-D90B-4A7E-A208-864AEE145536}" dt="2026-03-11T22:44:21.906" v="1738" actId="14100"/>
           <ac:cxnSpMkLst>
@@ -1098,22 +803,6 @@
           </ac:cxnSpMkLst>
         </pc:cxnChg>
         <pc:cxnChg chg="add mod">
-          <ac:chgData name="Johnson, Jared D (DOH)" userId="92504013-c597-429b-a67d-c586dbfe9781" providerId="ADAL" clId="{A79EF7B5-D90B-4A7E-A208-864AEE145536}" dt="2026-03-11T23:02:59.288" v="1981"/>
-          <ac:cxnSpMkLst>
-            <pc:docMk/>
-            <pc:sldMk cId="1410328859" sldId="258"/>
-            <ac:cxnSpMk id="1094" creationId="{AFF02F2B-CFE7-8265-3648-162B782C7C12}"/>
-          </ac:cxnSpMkLst>
-        </pc:cxnChg>
-        <pc:cxnChg chg="add del mod">
-          <ac:chgData name="Johnson, Jared D (DOH)" userId="92504013-c597-429b-a67d-c586dbfe9781" providerId="ADAL" clId="{A79EF7B5-D90B-4A7E-A208-864AEE145536}" dt="2026-03-11T23:03:02.243" v="1983" actId="21"/>
-          <ac:cxnSpMkLst>
-            <pc:docMk/>
-            <pc:sldMk cId="1410328859" sldId="258"/>
-            <ac:cxnSpMk id="1095" creationId="{18E38841-CACD-31DA-4461-AB06E37C9A9D}"/>
-          </ac:cxnSpMkLst>
-        </pc:cxnChg>
-        <pc:cxnChg chg="add mod">
           <ac:chgData name="Johnson, Jared D (DOH)" userId="92504013-c597-429b-a67d-c586dbfe9781" providerId="ADAL" clId="{A79EF7B5-D90B-4A7E-A208-864AEE145536}" dt="2026-03-12T15:49:58.594" v="2305" actId="14100"/>
           <ac:cxnSpMkLst>
             <pc:docMk/>
@@ -1122,27 +811,11 @@
           </ac:cxnSpMkLst>
         </pc:cxnChg>
         <pc:cxnChg chg="add del mod">
-          <ac:chgData name="Johnson, Jared D (DOH)" userId="92504013-c597-429b-a67d-c586dbfe9781" providerId="ADAL" clId="{A79EF7B5-D90B-4A7E-A208-864AEE145536}" dt="2026-03-11T23:09:08.467" v="2112" actId="478"/>
-          <ac:cxnSpMkLst>
-            <pc:docMk/>
-            <pc:sldMk cId="1410328859" sldId="258"/>
-            <ac:cxnSpMk id="1133" creationId="{2DF01FEE-7A2A-F3B4-2D00-5DD1B3A58E4F}"/>
-          </ac:cxnSpMkLst>
-        </pc:cxnChg>
-        <pc:cxnChg chg="add del mod">
           <ac:chgData name="Johnson, Jared D (DOH)" userId="92504013-c597-429b-a67d-c586dbfe9781" providerId="ADAL" clId="{A79EF7B5-D90B-4A7E-A208-864AEE145536}" dt="2026-03-12T15:50:32.631" v="2312" actId="14100"/>
           <ac:cxnSpMkLst>
             <pc:docMk/>
             <pc:sldMk cId="1410328859" sldId="258"/>
             <ac:cxnSpMk id="1135" creationId="{99AE16FE-6212-C68B-3F8F-EE99E937DA53}"/>
-          </ac:cxnSpMkLst>
-        </pc:cxnChg>
-        <pc:cxnChg chg="add del mod">
-          <ac:chgData name="Johnson, Jared D (DOH)" userId="92504013-c597-429b-a67d-c586dbfe9781" providerId="ADAL" clId="{A79EF7B5-D90B-4A7E-A208-864AEE145536}" dt="2026-03-12T15:54:35.943" v="2431" actId="478"/>
-          <ac:cxnSpMkLst>
-            <pc:docMk/>
-            <pc:sldMk cId="1410328859" sldId="258"/>
-            <ac:cxnSpMk id="1156" creationId="{E8618A51-A14A-C571-DA22-8BF5E29BB718}"/>
           </ac:cxnSpMkLst>
         </pc:cxnChg>
         <pc:cxnChg chg="add mod">
@@ -1167,14 +840,6 @@
             <pc:docMk/>
             <pc:sldMk cId="1410328859" sldId="258"/>
             <ac:cxnSpMk id="1176" creationId="{90DC1FE3-2E2A-2F4E-17DD-C8FC03F8F222}"/>
-          </ac:cxnSpMkLst>
-        </pc:cxnChg>
-        <pc:cxnChg chg="add del mod">
-          <ac:chgData name="Johnson, Jared D (DOH)" userId="92504013-c597-429b-a67d-c586dbfe9781" providerId="ADAL" clId="{A79EF7B5-D90B-4A7E-A208-864AEE145536}" dt="2026-03-12T15:58:28.379" v="2665" actId="478"/>
-          <ac:cxnSpMkLst>
-            <pc:docMk/>
-            <pc:sldMk cId="1410328859" sldId="258"/>
-            <ac:cxnSpMk id="1182" creationId="{B202EB62-23ED-4BE4-0760-D7E0975CA1AD}"/>
           </ac:cxnSpMkLst>
         </pc:cxnChg>
         <pc:cxnChg chg="add mod">
@@ -1241,14 +906,6 @@
             <ac:cxnSpMk id="1556" creationId="{6632C962-D94C-71B4-591A-70067AA84E7C}"/>
           </ac:cxnSpMkLst>
         </pc:cxnChg>
-        <pc:cxnChg chg="add del mod">
-          <ac:chgData name="Johnson, Jared D (DOH)" userId="92504013-c597-429b-a67d-c586dbfe9781" providerId="ADAL" clId="{A79EF7B5-D90B-4A7E-A208-864AEE145536}" dt="2026-03-12T15:49:38.489" v="2302" actId="478"/>
-          <ac:cxnSpMkLst>
-            <pc:docMk/>
-            <pc:sldMk cId="1410328859" sldId="258"/>
-            <ac:cxnSpMk id="1562" creationId="{0921F6FD-DD3B-B595-3FD6-BEA2A549E48D}"/>
-          </ac:cxnSpMkLst>
-        </pc:cxnChg>
         <pc:cxnChg chg="add mod">
           <ac:chgData name="Johnson, Jared D (DOH)" userId="92504013-c597-429b-a67d-c586dbfe9781" providerId="ADAL" clId="{A79EF7B5-D90B-4A7E-A208-864AEE145536}" dt="2026-03-12T15:53:22.402" v="2370" actId="1076"/>
           <ac:cxnSpMkLst>
@@ -1361,7 +1018,7 @@
           <a:p>
             <a:fld id="{DB11FDA2-DF53-4058-90D9-8672BC23F2A5}" type="datetimeFigureOut">
               <a:rPr lang="en-US" smtClean="0"/>
-              <a:t>3/11/2026</a:t>
+              <a:t>4/3/2026</a:t>
             </a:fld>
             <a:endParaRPr lang="en-US"/>
           </a:p>
@@ -1867,7 +1524,7 @@
           <a:p>
             <a:fld id="{25BC61CE-F44F-4906-9012-02D52A6D4AED}" type="datetimeFigureOut">
               <a:rPr lang="en-US" smtClean="0"/>
-              <a:t>3/11/2026</a:t>
+              <a:t>4/3/2026</a:t>
             </a:fld>
             <a:endParaRPr lang="en-US"/>
           </a:p>
@@ -2037,7 +1694,7 @@
           <a:p>
             <a:fld id="{25BC61CE-F44F-4906-9012-02D52A6D4AED}" type="datetimeFigureOut">
               <a:rPr lang="en-US" smtClean="0"/>
-              <a:t>3/11/2026</a:t>
+              <a:t>4/3/2026</a:t>
             </a:fld>
             <a:endParaRPr lang="en-US"/>
           </a:p>
@@ -2217,7 +1874,7 @@
           <a:p>
             <a:fld id="{25BC61CE-F44F-4906-9012-02D52A6D4AED}" type="datetimeFigureOut">
               <a:rPr lang="en-US" smtClean="0"/>
-              <a:t>3/11/2026</a:t>
+              <a:t>4/3/2026</a:t>
             </a:fld>
             <a:endParaRPr lang="en-US"/>
           </a:p>
@@ -2387,7 +2044,7 @@
           <a:p>
             <a:fld id="{25BC61CE-F44F-4906-9012-02D52A6D4AED}" type="datetimeFigureOut">
               <a:rPr lang="en-US" smtClean="0"/>
-              <a:t>3/11/2026</a:t>
+              <a:t>4/3/2026</a:t>
             </a:fld>
             <a:endParaRPr lang="en-US"/>
           </a:p>
@@ -2633,7 +2290,7 @@
           <a:p>
             <a:fld id="{25BC61CE-F44F-4906-9012-02D52A6D4AED}" type="datetimeFigureOut">
               <a:rPr lang="en-US" smtClean="0"/>
-              <a:t>3/11/2026</a:t>
+              <a:t>4/3/2026</a:t>
             </a:fld>
             <a:endParaRPr lang="en-US"/>
           </a:p>
@@ -2865,7 +2522,7 @@
           <a:p>
             <a:fld id="{25BC61CE-F44F-4906-9012-02D52A6D4AED}" type="datetimeFigureOut">
               <a:rPr lang="en-US" smtClean="0"/>
-              <a:t>3/11/2026</a:t>
+              <a:t>4/3/2026</a:t>
             </a:fld>
             <a:endParaRPr lang="en-US"/>
           </a:p>
@@ -3232,7 +2889,7 @@
           <a:p>
             <a:fld id="{25BC61CE-F44F-4906-9012-02D52A6D4AED}" type="datetimeFigureOut">
               <a:rPr lang="en-US" smtClean="0"/>
-              <a:t>3/11/2026</a:t>
+              <a:t>4/3/2026</a:t>
             </a:fld>
             <a:endParaRPr lang="en-US"/>
           </a:p>
@@ -3350,7 +3007,7 @@
           <a:p>
             <a:fld id="{25BC61CE-F44F-4906-9012-02D52A6D4AED}" type="datetimeFigureOut">
               <a:rPr lang="en-US" smtClean="0"/>
-              <a:t>3/11/2026</a:t>
+              <a:t>4/3/2026</a:t>
             </a:fld>
             <a:endParaRPr lang="en-US"/>
           </a:p>
@@ -3445,7 +3102,7 @@
           <a:p>
             <a:fld id="{25BC61CE-F44F-4906-9012-02D52A6D4AED}" type="datetimeFigureOut">
               <a:rPr lang="en-US" smtClean="0"/>
-              <a:t>3/11/2026</a:t>
+              <a:t>4/3/2026</a:t>
             </a:fld>
             <a:endParaRPr lang="en-US"/>
           </a:p>
@@ -3722,7 +3379,7 @@
           <a:p>
             <a:fld id="{25BC61CE-F44F-4906-9012-02D52A6D4AED}" type="datetimeFigureOut">
               <a:rPr lang="en-US" smtClean="0"/>
-              <a:t>3/11/2026</a:t>
+              <a:t>4/3/2026</a:t>
             </a:fld>
             <a:endParaRPr lang="en-US"/>
           </a:p>
@@ -3979,7 +3636,7 @@
           <a:p>
             <a:fld id="{25BC61CE-F44F-4906-9012-02D52A6D4AED}" type="datetimeFigureOut">
               <a:rPr lang="en-US" smtClean="0"/>
-              <a:t>3/11/2026</a:t>
+              <a:t>4/3/2026</a:t>
             </a:fld>
             <a:endParaRPr lang="en-US"/>
           </a:p>
@@ -4192,7 +3849,7 @@
           <a:p>
             <a:fld id="{25BC61CE-F44F-4906-9012-02D52A6D4AED}" type="datetimeFigureOut">
               <a:rPr lang="en-US" smtClean="0"/>
-              <a:t>3/11/2026</a:t>
+              <a:t>4/3/2026</a:t>
             </a:fld>
             <a:endParaRPr lang="en-US"/>
           </a:p>
@@ -5080,7 +4737,21 @@
                   <a:latin typeface="Maven pro" pitchFamily="2" charset="0"/>
                   <a:cs typeface="Baloo 2" pitchFamily="2" charset="0"/>
                 </a:rPr>
-                <a:t>DOH-JDJ0303/</a:t>
+                <a:t>NW-</a:t>
+              </a:r>
+              <a:r>
+                <a:rPr lang="en-US" sz="10800" dirty="0" err="1">
+                  <a:latin typeface="Maven pro" pitchFamily="2" charset="0"/>
+                  <a:cs typeface="Baloo 2" pitchFamily="2" charset="0"/>
+                </a:rPr>
+                <a:t>PaGe</a:t>
+              </a:r>
+              <a:r>
+                <a:rPr lang="en-US" sz="10800" dirty="0">
+                  <a:latin typeface="Maven pro" pitchFamily="2" charset="0"/>
+                  <a:cs typeface="Baloo 2" pitchFamily="2" charset="0"/>
+                </a:rPr>
+                <a:t>/</a:t>
               </a:r>
             </a:p>
             <a:p>
@@ -5289,8 +4960,8 @@
         </p:blipFill>
         <p:spPr>
           <a:xfrm>
-            <a:off x="3208295" y="2617091"/>
-            <a:ext cx="10058400" cy="10058400"/>
+            <a:off x="2714436" y="2154182"/>
+            <a:ext cx="10887707" cy="10887707"/>
           </a:xfrm>
           <a:prstGeom prst="rect">
             <a:avLst/>
@@ -10037,6 +9708,25 @@
 </file>
 
 <file path=customXml/item1.xml><?xml version="1.0" encoding="utf-8"?>
+<p:properties xmlns:p="http://schemas.microsoft.com/office/2006/metadata/properties" xmlns:xsi="http://www.w3.org/2001/XMLSchema-instance" xmlns:pc="http://schemas.microsoft.com/office/infopath/2007/PartnerControls">
+  <documentManagement>
+    <_ip_UnifiedCompliancePolicyUIAction xmlns="http://schemas.microsoft.com/sharepoint/v3" xsi:nil="true"/>
+    <_activity xmlns="f2b62b15-80e1-4d0a-840a-7bfa1a84b0ef" xsi:nil="true"/>
+    <_ip_UnifiedCompliancePolicyProperties xmlns="http://schemas.microsoft.com/sharepoint/v3" xsi:nil="true"/>
+  </documentManagement>
+</p:properties>
+</file>
+
+<file path=customXml/item2.xml><?xml version="1.0" encoding="utf-8"?>
+<?mso-contentType ?>
+<FormTemplates xmlns="http://schemas.microsoft.com/sharepoint/v3/contenttype/forms">
+  <Display>DocumentLibraryForm</Display>
+  <Edit>DocumentLibraryForm</Edit>
+  <New>DocumentLibraryForm</New>
+</FormTemplates>
+</file>
+
+<file path=customXml/item3.xml><?xml version="1.0" encoding="utf-8"?>
 <ct:contentTypeSchema xmlns:ct="http://schemas.microsoft.com/office/2006/metadata/contentType" xmlns:ma="http://schemas.microsoft.com/office/2006/metadata/properties/metaAttributes" ct:_="" ma:_="" ma:contentTypeName="Document" ma:contentTypeID="0x010100C469B16BD5DABD47B6EC6D6046690504" ma:contentTypeVersion="17" ma:contentTypeDescription="Create a new document." ma:contentTypeScope="" ma:versionID="a8c302c69d56c4b2f78e7847c60627f7">
   <xsd:schema xmlns:xsd="http://www.w3.org/2001/XMLSchema" xmlns:xs="http://www.w3.org/2001/XMLSchema" xmlns:p="http://schemas.microsoft.com/office/2006/metadata/properties" xmlns:ns1="http://schemas.microsoft.com/sharepoint/v3" xmlns:ns3="f2b62b15-80e1-4d0a-840a-7bfa1a84b0ef" xmlns:ns4="3b12a43a-d46c-442c-80ed-850136c6366a" targetNamespace="http://schemas.microsoft.com/office/2006/metadata/properties" ma:root="true" ma:fieldsID="dbad766ee67e3b6ba6e937223de5da7b" ns1:_="" ns3:_="" ns4:_="">
     <xsd:import namespace="http://schemas.microsoft.com/sharepoint/v3"/>
@@ -10286,26 +9976,33 @@
 </ct:contentTypeSchema>
 </file>
 
-<file path=customXml/item2.xml><?xml version="1.0" encoding="utf-8"?>
-<?mso-contentType ?>
-<FormTemplates xmlns="http://schemas.microsoft.com/sharepoint/v3/contenttype/forms">
-  <Display>DocumentLibraryForm</Display>
-  <Edit>DocumentLibraryForm</Edit>
-  <New>DocumentLibraryForm</New>
-</FormTemplates>
+<file path=customXml/itemProps1.xml><?xml version="1.0" encoding="utf-8"?>
+<ds:datastoreItem xmlns:ds="http://schemas.openxmlformats.org/officeDocument/2006/customXml" ds:itemID="{F65B05CD-C345-42A3-A57E-AAC5C0E995D7}">
+  <ds:schemaRefs>
+    <ds:schemaRef ds:uri="http://schemas.microsoft.com/office/2006/metadata/properties"/>
+    <ds:schemaRef ds:uri="http://schemas.microsoft.com/office/2006/documentManagement/types"/>
+    <ds:schemaRef ds:uri="3b12a43a-d46c-442c-80ed-850136c6366a"/>
+    <ds:schemaRef ds:uri="http://www.w3.org/XML/1998/namespace"/>
+    <ds:schemaRef ds:uri="http://schemas.microsoft.com/office/infopath/2007/PartnerControls"/>
+    <ds:schemaRef ds:uri="http://schemas.microsoft.com/sharepoint/v3"/>
+    <ds:schemaRef ds:uri="http://purl.org/dc/elements/1.1/"/>
+    <ds:schemaRef ds:uri="http://purl.org/dc/terms/"/>
+    <ds:schemaRef ds:uri="http://schemas.openxmlformats.org/package/2006/metadata/core-properties"/>
+    <ds:schemaRef ds:uri="f2b62b15-80e1-4d0a-840a-7bfa1a84b0ef"/>
+    <ds:schemaRef ds:uri="http://purl.org/dc/dcmitype/"/>
+  </ds:schemaRefs>
+</ds:datastoreItem>
 </file>
 
-<file path=customXml/item3.xml><?xml version="1.0" encoding="utf-8"?>
-<p:properties xmlns:p="http://schemas.microsoft.com/office/2006/metadata/properties" xmlns:xsi="http://www.w3.org/2001/XMLSchema-instance" xmlns:pc="http://schemas.microsoft.com/office/infopath/2007/PartnerControls">
-  <documentManagement>
-    <_ip_UnifiedCompliancePolicyUIAction xmlns="http://schemas.microsoft.com/sharepoint/v3" xsi:nil="true"/>
-    <_activity xmlns="f2b62b15-80e1-4d0a-840a-7bfa1a84b0ef" xsi:nil="true"/>
-    <_ip_UnifiedCompliancePolicyProperties xmlns="http://schemas.microsoft.com/sharepoint/v3" xsi:nil="true"/>
-  </documentManagement>
-</p:properties>
+<file path=customXml/itemProps2.xml><?xml version="1.0" encoding="utf-8"?>
+<ds:datastoreItem xmlns:ds="http://schemas.openxmlformats.org/officeDocument/2006/customXml" ds:itemID="{7EFEC442-C14D-411E-B6E7-419DFE747B35}">
+  <ds:schemaRefs>
+    <ds:schemaRef ds:uri="http://schemas.microsoft.com/sharepoint/v3/contenttype/forms"/>
+  </ds:schemaRefs>
+</ds:datastoreItem>
 </file>
 
-<file path=customXml/itemProps1.xml><?xml version="1.0" encoding="utf-8"?>
+<file path=customXml/itemProps3.xml><?xml version="1.0" encoding="utf-8"?>
 <ds:datastoreItem xmlns:ds="http://schemas.openxmlformats.org/officeDocument/2006/customXml" ds:itemID="{05C0CC8F-76A1-4514-A797-CD71E98FB070}">
   <ds:schemaRefs>
     <ds:schemaRef ds:uri="http://schemas.microsoft.com/office/2006/metadata/contentType"/>
@@ -10325,32 +10022,6 @@
 </ds:datastoreItem>
 </file>
 
-<file path=customXml/itemProps2.xml><?xml version="1.0" encoding="utf-8"?>
-<ds:datastoreItem xmlns:ds="http://schemas.openxmlformats.org/officeDocument/2006/customXml" ds:itemID="{7EFEC442-C14D-411E-B6E7-419DFE747B35}">
-  <ds:schemaRefs>
-    <ds:schemaRef ds:uri="http://schemas.microsoft.com/sharepoint/v3/contenttype/forms"/>
-  </ds:schemaRefs>
-</ds:datastoreItem>
-</file>
-
-<file path=customXml/itemProps3.xml><?xml version="1.0" encoding="utf-8"?>
-<ds:datastoreItem xmlns:ds="http://schemas.openxmlformats.org/officeDocument/2006/customXml" ds:itemID="{F65B05CD-C345-42A3-A57E-AAC5C0E995D7}">
-  <ds:schemaRefs>
-    <ds:schemaRef ds:uri="http://purl.org/dc/elements/1.1/"/>
-    <ds:schemaRef ds:uri="http://purl.org/dc/terms/"/>
-    <ds:schemaRef ds:uri="f2b62b15-80e1-4d0a-840a-7bfa1a84b0ef"/>
-    <ds:schemaRef ds:uri="http://schemas.microsoft.com/office/2006/documentManagement/types"/>
-    <ds:schemaRef ds:uri="http://www.w3.org/XML/1998/namespace"/>
-    <ds:schemaRef ds:uri="http://schemas.openxmlformats.org/package/2006/metadata/core-properties"/>
-    <ds:schemaRef ds:uri="http://schemas.microsoft.com/sharepoint/v3"/>
-    <ds:schemaRef ds:uri="http://purl.org/dc/dcmitype/"/>
-    <ds:schemaRef ds:uri="http://schemas.microsoft.com/office/infopath/2007/PartnerControls"/>
-    <ds:schemaRef ds:uri="3b12a43a-d46c-442c-80ed-850136c6366a"/>
-    <ds:schemaRef ds:uri="http://schemas.microsoft.com/office/2006/metadata/properties"/>
-  </ds:schemaRefs>
-</ds:datastoreItem>
-</file>
-
 <file path=docMetadata/LabelInfo.xml><?xml version="1.0" encoding="utf-8"?>
 <clbl:labelList xmlns:clbl="http://schemas.microsoft.com/office/2020/mipLabelMetadata">
   <clbl:label id="{1520fa42-cf58-4c22-8b93-58cf1d3bd1cb}" enabled="1" method="Standard" siteId="{11d0e217-264e-400a-8ba0-57dcc127d72d}" removed="0"/>

</xml_diff>